<commit_message>
Agrega enlace al video de la exposicion; informe solo en PDF y sin guion
</commit_message>
<xml_diff>
--- a/docs/entregables/Avance03_Exposicion_LAFORSE.pptx
+++ b/docs/entregables/Avance03_Exposicion_LAFORSE.pptx
@@ -7785,6 +7785,101 @@
         </p:nvSpPr>
         <p:spPr>
           <a:xfrm>
+            <a:off x="502920" y="6053328"/>
+            <a:ext cx="8778240" cy="365760"/>
+          </a:xfrm>
+          <a:prstGeom prst="rect">
+            <a:avLst/>
+          </a:prstGeom>
+          <a:noFill/>
+          <a:ln/>
+        </p:spPr>
+        <p:txBody>
+          <a:bodyPr wrap="square" lIns="0" tIns="0" rIns="0" bIns="0" rtlCol="0" anchor="t"/>
+          <a:lstStyle/>
+          <a:p>
+            <a:pPr indent="0" marL="0">
+              <a:buNone/>
+            </a:pPr>
+            <a:r>
+              <a:rPr lang="en-US" sz="1300" b="1" dirty="0">
+                <a:solidFill>
+                  <a:srgbClr val="13A3B4"/>
+                </a:solidFill>
+                <a:latin typeface="Calibri" pitchFamily="34" charset="0"/>
+                <a:ea typeface="Calibri" pitchFamily="34" charset="-122"/>
+                <a:cs typeface="Calibri" pitchFamily="34" charset="-120"/>
+              </a:rPr>
+              <a:t>Video: </a:t>
+            </a:r>
+            <a:pPr indent="0" marL="0">
+              <a:buNone/>
+            </a:pPr>
+            <a:r>
+              <a:rPr lang="en-US" sz="1300" u="sng" dirty="0">
+                <a:solidFill>
+                  <a:srgbClr val="C9D6E0"/>
+                </a:solidFill>
+                <a:latin typeface="Calibri" pitchFamily="34" charset="0"/>
+                <a:ea typeface="Calibri" pitchFamily="34" charset="-122"/>
+                <a:cs typeface="Calibri" pitchFamily="34" charset="-120"/>
+                <a:hlinkClick r:id="rId1" invalidUrl="" action="" tgtFrame="" tooltip="" history="1" highlightClick="0" endSnd="0">
+                  <a:extLst>
+                    <a:ext uri="{A12FA001-AC4F-418D-AE19-62706E023703}">
+                      <ahyp:hlinkClr xmlns:ahyp="http://schemas.microsoft.com/office/drawing/2018/hyperlinkcolor" val="tx"/>
+                    </a:ext>
+                  </a:extLst>
+                </a:hlinkClick>
+              </a:rPr>
+              <a:t>youtube.com/playlist?list=PLMEk-IU6stbw</a:t>
+            </a:r>
+            <a:pPr indent="0" marL="0">
+              <a:buNone/>
+            </a:pPr>
+            <a:r>
+              <a:rPr lang="en-US" sz="1300" b="1" dirty="0">
+                <a:solidFill>
+                  <a:srgbClr val="13A3B4"/>
+                </a:solidFill>
+                <a:latin typeface="Calibri" pitchFamily="34" charset="0"/>
+                <a:ea typeface="Calibri" pitchFamily="34" charset="-122"/>
+                <a:cs typeface="Calibri" pitchFamily="34" charset="-120"/>
+              </a:rPr>
+              <a:t>      Código: </a:t>
+            </a:r>
+            <a:pPr indent="0" marL="0">
+              <a:buNone/>
+            </a:pPr>
+            <a:r>
+              <a:rPr lang="en-US" sz="1300" u="sng" dirty="0">
+                <a:solidFill>
+                  <a:srgbClr val="C9D6E0"/>
+                </a:solidFill>
+                <a:latin typeface="Calibri" pitchFamily="34" charset="0"/>
+                <a:ea typeface="Calibri" pitchFamily="34" charset="-122"/>
+                <a:cs typeface="Calibri" pitchFamily="34" charset="-120"/>
+                <a:hlinkClick r:id="rId2" invalidUrl="" action="" tgtFrame="" tooltip="" history="1" highlightClick="0" endSnd="0">
+                  <a:extLst>
+                    <a:ext uri="{A12FA001-AC4F-418D-AE19-62706E023703}">
+                      <ahyp:hlinkClr xmlns:ahyp="http://schemas.microsoft.com/office/drawing/2018/hyperlinkcolor" val="tx"/>
+                    </a:ext>
+                  </a:extLst>
+                </a:hlinkClick>
+              </a:rPr>
+              <a:t>github.com/jcolchadochavez/laforse-web-avance3</a:t>
+            </a:r>
+            <a:endParaRPr lang="en-US" sz="1300" dirty="0"/>
+          </a:p>
+        </p:txBody>
+      </p:sp>
+      <p:sp>
+        <p:nvSpPr>
+          <p:cNvPr id="18" name="Text 16"/>
+          <p:cNvSpPr txBox="1"/>
+          <p:nvPr/>
+        </p:nvSpPr>
+        <p:spPr>
+          <a:xfrm>
             <a:off x="8945575" y="5989320"/>
             <a:ext cx="2743200" cy="457200"/>
           </a:xfrm>

</xml_diff>